<commit_message>
docs(deliverables): regenerate review report + pitch deck with wave-5 stats (402 fitments, 74 products); publish review copies at /report-v2/
</commit_message>
<xml_diff>
--- a/report-v2/Vehicle_Selector_Pro_Pitch_Deck.pptx
+++ b/report-v2/Vehicle_Selector_Pro_Pitch_Deck.pptx
@@ -4477,7 +4477,7 @@
                 </a:solidFill>
                 <a:latin typeface="Calibri"/>
               </a:rPr>
-              <a:t>318</a:t>
+              <a:t>402</a:t>
             </a:r>
           </a:p>
         </p:txBody>
@@ -4583,7 +4583,7 @@
                 </a:solidFill>
                 <a:latin typeface="Calibri"/>
               </a:rPr>
-              <a:t>54</a:t>
+              <a:t>74</a:t>
             </a:r>
           </a:p>
         </p:txBody>

</xml_diff>